<commit_message>
Add scale-ratio and rotation-edge robustness results to the deck
</commit_message>
<xml_diff>
--- a/DriftSense_Submission_12slides.pptx
+++ b/DriftSense_Submission_12slides.pptx
@@ -6233,7 +6233,7 @@
         </p:nvSpPr>
         <p:spPr>
           <a:xfrm>
-            <a:off x="1200607" y="4082796"/>
+            <a:off x="1200607" y="4030000"/>
             <a:ext cx="1271930" cy="191110"/>
           </a:xfrm>
           <a:prstGeom prst="rect">
@@ -6288,7 +6288,7 @@
             <a:pPr marL="0" indent="0" algn="l">
               <a:buNone/>
             </a:pPr>
-            <a:endParaRPr lang="en-US" sz="1200" i="1" dirty="0">
+            <a:endParaRPr lang="en-US" sz="1050" i="1" dirty="0">
               <a:solidFill>
                 <a:srgbClr val="FFFFFF">
                   <a:alpha val="70000"/>
@@ -6303,7 +6303,7 @@
             <a:pPr marL="0" indent="0" algn="l">
               <a:buNone/>
             </a:pPr>
-            <a:endParaRPr lang="en-US" sz="1200" i="1" dirty="0">
+            <a:endParaRPr lang="en-US" sz="1050" i="1" dirty="0">
               <a:solidFill>
                 <a:srgbClr val="FFFFFF">
                   <a:alpha val="70000"/>
@@ -6318,7 +6318,7 @@
             <a:pPr marL="0" indent="0" algn="l">
               <a:buNone/>
             </a:pPr>
-            <a:endParaRPr lang="en-US" sz="1200" i="1" dirty="0">
+            <a:endParaRPr lang="en-US" sz="1050" i="1" dirty="0">
               <a:solidFill>
                 <a:srgbClr val="FFFFFF">
                   <a:alpha val="70000"/>
@@ -6333,7 +6333,7 @@
             <a:pPr marL="0" indent="0" algn="l">
               <a:buNone/>
             </a:pPr>
-            <a:endParaRPr lang="en-US" sz="1200" i="1" dirty="0">
+            <a:endParaRPr lang="en-US" sz="1050" i="1" dirty="0">
               <a:solidFill>
                 <a:srgbClr val="FFFFFF">
                   <a:alpha val="70000"/>
@@ -6348,7 +6348,7 @@
             <a:pPr marL="0" indent="0" algn="l">
               <a:buNone/>
             </a:pPr>
-            <a:endParaRPr lang="en-US" sz="1200" i="1" dirty="0">
+            <a:endParaRPr lang="en-US" sz="1050" i="1" dirty="0">
               <a:solidFill>
                 <a:srgbClr val="FFFFFF">
                   <a:alpha val="70000"/>
@@ -6363,7 +6363,7 @@
             <a:pPr marL="0" indent="0" algn="l">
               <a:buNone/>
             </a:pPr>
-            <a:endParaRPr lang="en-US" sz="1200" i="1" dirty="0">
+            <a:endParaRPr lang="en-US" sz="1050" i="1" dirty="0">
               <a:solidFill>
                 <a:srgbClr val="FFFFFF">
                   <a:alpha val="70000"/>
@@ -6378,7 +6378,7 @@
             <a:pPr marL="0" indent="0" algn="l">
               <a:buNone/>
             </a:pPr>
-            <a:endParaRPr lang="en-US" sz="1200" i="1" dirty="0">
+            <a:endParaRPr lang="en-US" sz="1050" i="1" dirty="0">
               <a:solidFill>
                 <a:srgbClr val="FFFFFF">
                   <a:alpha val="70000"/>
@@ -6393,7 +6393,7 @@
             <a:pPr marL="0" indent="0" algn="l">
               <a:buNone/>
             </a:pPr>
-            <a:endParaRPr lang="en-US" sz="1200" i="1" dirty="0">
+            <a:endParaRPr lang="en-US" sz="1050" i="1" dirty="0">
               <a:solidFill>
                 <a:srgbClr val="FFFFFF">
                   <a:alpha val="70000"/>
@@ -6409,7 +6409,7 @@
               <a:buNone/>
             </a:pPr>
             <a:r>
-              <a:rPr lang="en-US" sz="1200" i="1" dirty="0">
+              <a:rPr lang="en-US" sz="1050" i="1" dirty="0">
                 <a:solidFill>
                   <a:srgbClr val="FFFFFF">
                     <a:alpha val="70000"/>
@@ -6421,14 +6421,14 @@
               </a:rPr>
               <a:t>Layered die realism, each layer measured: one uniform array 40 % under fingerprint ablation; mats + strips 90 %; micron landmarks 95 %.</a:t>
             </a:r>
-            <a:endParaRPr lang="en-US" sz="1200" dirty="0"/>
-          </a:p>
-          <a:p>
-            <a:pPr marL="0" indent="0" algn="l">
-              <a:buNone/>
-            </a:pPr>
-            <a:r>
-              <a:rPr lang="en-US" sz="1200" i="1" dirty="0">
+            <a:endParaRPr lang="en-US" sz="1050" dirty="0"/>
+          </a:p>
+          <a:p>
+            <a:pPr marL="0" indent="0" algn="l">
+              <a:buNone/>
+            </a:pPr>
+            <a:r>
+              <a:rPr lang="en-US" sz="1050" i="1" dirty="0">
                 <a:solidFill>
                   <a:srgbClr val="FFFFFF">
                     <a:alpha val="70000"/>
@@ -6440,14 +6440,14 @@
               </a:rPr>
               <a:t>Honest ablation shipped: the --visual-clarity flag makes cleaner images by disabling both cues — it costs 24 points (71.2 %), off by default.</a:t>
             </a:r>
-            <a:endParaRPr lang="en-US" sz="1200" dirty="0"/>
-          </a:p>
-          <a:p>
-            <a:pPr marL="0" indent="0" algn="l">
-              <a:buNone/>
-            </a:pPr>
-            <a:r>
-              <a:rPr lang="en-US" sz="1200" i="1" dirty="0">
+            <a:endParaRPr lang="en-US" sz="1050" dirty="0"/>
+          </a:p>
+          <a:p>
+            <a:pPr marL="0" indent="0" algn="l">
+              <a:buNone/>
+            </a:pPr>
+            <a:r>
+              <a:rPr lang="en-US" sz="1050" i="1" dirty="0">
                 <a:solidFill>
                   <a:srgbClr val="FFFFFF">
                     <a:alpha val="70000"/>
@@ -6459,7 +6459,26 @@
               </a:rPr>
               <a:t>Fingerprint fully disabled (--pv-amplitude 0.0, seed 404): still 19/20, median 0.10 px — the non-periodic micron landmarks carry it alone.</a:t>
             </a:r>
-            <a:endParaRPr lang="en-US" sz="1200" dirty="0"/>
+            <a:endParaRPr lang="en-US" sz="1050" dirty="0"/>
+          </a:p>
+          <a:p>
+            <a:pPr marL="0" indent="0" algn="l">
+              <a:buNone/>
+            </a:pPr>
+            <a:r>
+              <a:rPr lang="en-US" sz="1050" i="1" dirty="0">
+                <a:solidFill>
+                  <a:srgbClr val="FFFFFF">
+                    <a:alpha val="70000"/>
+                  </a:srgbClr>
+                </a:solidFill>
+                <a:latin typeface="Poppins" pitchFamily="34" charset="0"/>
+                <a:ea typeface="Poppins" pitchFamily="34" charset="-122"/>
+                <a:cs typeface="Poppins" pitchFamily="34" charset="-120"/>
+              </a:rPr>
+              <a:t>Scale and rotation edges also hold: 9:1 and 11:1 magnification ratio both 100% (20/20); 2° rotation edge 100% (20/20) — no measurable cost outside the nominal 10:1 / 1.5° defaults.</a:t>
+            </a:r>
+            <a:endParaRPr lang="en-US" sz="1050" dirty="0"/>
           </a:p>
         </p:txBody>
       </p:sp>
@@ -12346,7 +12365,7 @@
               <a:buNone/>
             </a:pPr>
             <a:r>
-              <a:rPr lang="en-US" sz="1200" b="1" dirty="0">
+              <a:rPr lang="en-US" sz="1050" b="1" dirty="0">
                 <a:solidFill>
                   <a:srgbClr val="FFFFFF"/>
                 </a:solidFill>
@@ -12356,7 +12375,7 @@
               </a:rPr>
               <a:t>Quantifiable Outcomes</a:t>
             </a:r>
-            <a:endParaRPr lang="en-US" sz="1200" dirty="0"/>
+            <a:endParaRPr lang="en-US" sz="1050" dirty="0"/>
           </a:p>
         </p:txBody>
       </p:sp>
@@ -12368,7 +12387,7 @@
         </p:nvSpPr>
         <p:spPr>
           <a:xfrm>
-            <a:off x="6448349" y="4900000"/>
+            <a:off x="6448349" y="5010000"/>
             <a:ext cx="4200000" cy="381305"/>
           </a:xfrm>
           <a:prstGeom prst="rect">
@@ -12458,7 +12477,7 @@
                 <a:ea typeface="Poppins" pitchFamily="34" charset="-122"/>
                 <a:cs typeface="Poppins" pitchFamily="34" charset="-120"/>
               </a:rPr>
-              <a:t>93.75 % within 5 px — 75/80 pairs over four independent seeds (20/20 · 19/20 · 19/20 · 17/20). Mean 21.4 px, worst-case 721 px — rare full lattice jumps, not near-misses.</a:t>
+              <a:t>Threshold-wise (75/80 pairs, four seeds): ≤5px 93.75% — ≤4px 93.75% — ≤2px 91.25% — ≤1px (sub-pixel) 90.0%.</a:t>
             </a:r>
             <a:endParaRPr lang="en-US" sz="1000" dirty="0"/>
           </a:p>
@@ -12476,6 +12495,23 @@
                 <a:cs typeface="Poppins" pitchFamily="34" charset="-120"/>
               </a:rPr>
               <a:t>Median localization error 0.10 px — sub-pixel.</a:t>
+            </a:r>
+            <a:endParaRPr lang="en-US" sz="1000" dirty="0"/>
+          </a:p>
+          <a:p>
+            <a:pPr marL="0" indent="0" algn="l">
+              <a:buNone/>
+            </a:pPr>
+            <a:r>
+              <a:rPr lang="en-US" sz="1000" dirty="0">
+                <a:solidFill>
+                  <a:srgbClr val="D1D5DB"/>
+                </a:solidFill>
+                <a:latin typeface="Poppins" pitchFamily="34" charset="0"/>
+                <a:ea typeface="Poppins" pitchFamily="34" charset="-122"/>
+                <a:cs typeface="Poppins" pitchFamily="34" charset="-120"/>
+              </a:rPr>
+              <a:t>Error stats: mean 21.4 px, worst-case 721 px — rare full lattice jumps, not near-misses.</a:t>
             </a:r>
             <a:endParaRPr lang="en-US" sz="1000" dirty="0"/>
           </a:p>

</xml_diff>